<commit_message>
Add a five-minute review deck, and credit the team
The existing deck is a twenty-five minute talk. A five-minute slot needs a
different deck, not a trimmed one: seven slides, each with the timing it should
land at in the speaker notes. It keeps the assumption that is wrong, the
measurement, the equity problem we found in our own fix, the result, and the
fact that all of it re-runs on demand -- and drops everything else.

Rishab CV (24BCE5296) and Martin Wills (24BCE5255) are credited on both decks
and in the README.
</commit_message>
<xml_diff>
--- a/docs/deck/SmartTraffic-SIH-PS90.pptx
+++ b/docs/deck/SmartTraffic-SIH-PS90.pptx
@@ -120,44 +120,44 @@
   <p:extLst>
     <p:ext uri="{521415D9-36F7-43E2-AB2F-B90AF26B5E84}">
       <p14:sectionLst xmlns:p14="http://schemas.microsoft.com/office/powerpoint/2010/main">
-        <p14:section name="Opening" id="{450e6223-e32e-c0fd-3cfc-a6af7aeca0cd}">
+        <p14:section name="Opening" id="{0057f988-90c6-0808-30bf-5afcb09d0582}">
           <p14:sldIdLst>
             <p14:sldId id="256"/>
           </p14:sldIdLst>
         </p14:section>
-        <p14:section name="Problem" id="{93871322-ec25-97de-aaf0-29d3e462f8d8}">
+        <p14:section name="Problem" id="{14f081f9-e4f6-cd8d-8c6d-246976a81885}">
           <p14:sldIdLst>
             <p14:sldId id="257"/>
             <p14:sldId id="258"/>
           </p14:sldIdLst>
         </p14:section>
-        <p14:section name="The novelty" id="{2e21a506-4f69-7b2a-e1b9-375eb99d400e}">
+        <p14:section name="The novelty" id="{bd1e0452-7945-f7ce-87da-f71be93c5dc6}">
           <p14:sldIdLst>
             <p14:sldId id="259"/>
             <p14:sldId id="260"/>
             <p14:sldId id="261"/>
           </p14:sldIdLst>
         </p14:section>
-        <p14:section name="Method" id="{59155ddf-f34f-ac97-f0ca-e5bf95cff53f}">
+        <p14:section name="Method" id="{af729c79-e790-5105-0cad-882f98f57853}">
           <p14:sldIdLst>
             <p14:sldId id="262"/>
           </p14:sldIdLst>
         </p14:section>
-        <p14:section name="Results" id="{26457fc1-9b3f-8038-624f-eea5f5d0f731}">
+        <p14:section name="Results" id="{37b72acf-2c96-f4cc-2421-be6139c5f48e}">
           <p14:sldIdLst>
             <p14:sldId id="263"/>
             <p14:sldId id="264"/>
             <p14:sldId id="265"/>
           </p14:sldIdLst>
         </p14:section>
-        <p14:section name="Deployability" id="{3baa5d67-4754-dab3-cf37-d8d32a3722d4}">
+        <p14:section name="Deployability" id="{4a5d0ecd-bd19-6103-6bb9-f939a1ced275}">
           <p14:sldIdLst>
             <p14:sldId id="266"/>
             <p14:sldId id="267"/>
             <p14:sldId id="268"/>
           </p14:sldIdLst>
         </p14:section>
-        <p14:section name="Close" id="{88714a02-13c3-5c03-70f7-d96e1c566c7b}">
+        <p14:section name="Close" id="{11176125-90bb-c869-766c-2d7476ca7e94}">
           <p14:sldIdLst>
             <p14:sldId id="269"/>
           </p14:sldIdLst>
@@ -4047,7 +4047,128 @@
       </p:sp>
       <p:sp>
         <p:nvSpPr>
-          <p:cNvPr id="4" name="signal housing"/>
+          <p:cNvPr id="4" name="team card"/>
+          <p:cNvSpPr/>
+          <p:nvPr/>
+        </p:nvSpPr>
+        <p:spPr>
+          <a:xfrm>
+            <a:off x="640080" y="5257800"/>
+            <a:ext cx="6035040" cy="1051560"/>
+          </a:xfrm>
+          <a:prstGeom prst="roundRect">
+            <a:avLst>
+              <a:gd name="adj" fmla="val 6957"/>
+            </a:avLst>
+          </a:prstGeom>
+          <a:solidFill>
+            <a:srgbClr val="1B2A3A"/>
+          </a:solidFill>
+          <a:ln w="12700">
+            <a:solidFill>
+              <a:srgbClr val="1B2A3A"/>
+            </a:solidFill>
+            <a:prstDash val="solid"/>
+          </a:ln>
+        </p:spPr>
+      </p:sp>
+      <p:sp>
+        <p:nvSpPr>
+          <p:cNvPr id="5" name="Text 3"/>
+          <p:cNvSpPr txBox="1"/>
+          <p:nvPr/>
+        </p:nvSpPr>
+        <p:spPr>
+          <a:xfrm>
+            <a:off x="960120" y="5394960"/>
+            <a:ext cx="5486400" cy="365760"/>
+          </a:xfrm>
+          <a:prstGeom prst="rect">
+            <a:avLst/>
+          </a:prstGeom>
+          <a:noFill/>
+          <a:ln/>
+        </p:spPr>
+        <p:txBody>
+          <a:bodyPr wrap="square" lIns="0" tIns="0" rIns="0" bIns="0" rtlCol="0" anchor="ctr"/>
+          <a:lstStyle/>
+          <a:p>
+            <a:pPr indent="0" marL="0">
+              <a:buNone/>
+            </a:pPr>
+            <a:r>
+              <a:rPr lang="en-US" sz="1500" b="1" dirty="0">
+                <a:solidFill>
+                  <a:srgbClr val="FFFFFF"/>
+                </a:solidFill>
+              </a:rPr>
+              <a:t>Rishab CV</a:t>
+            </a:r>
+            <a:pPr indent="0" marL="0">
+              <a:buNone/>
+            </a:pPr>
+            <a:r>
+              <a:rPr lang="en-US" sz="1500" dirty="0">
+                <a:solidFill>
+                  <a:srgbClr val="FFB347"/>
+                </a:solidFill>
+              </a:rPr>
+              <a:t>   24BCE5296</a:t>
+            </a:r>
+            <a:endParaRPr lang="en-US" sz="1500" dirty="0"/>
+          </a:p>
+        </p:txBody>
+      </p:sp>
+      <p:sp>
+        <p:nvSpPr>
+          <p:cNvPr id="6" name="Text 4"/>
+          <p:cNvSpPr txBox="1"/>
+          <p:nvPr/>
+        </p:nvSpPr>
+        <p:spPr>
+          <a:xfrm>
+            <a:off x="960120" y="5788152"/>
+            <a:ext cx="5486400" cy="365760"/>
+          </a:xfrm>
+          <a:prstGeom prst="rect">
+            <a:avLst/>
+          </a:prstGeom>
+          <a:noFill/>
+          <a:ln/>
+        </p:spPr>
+        <p:txBody>
+          <a:bodyPr wrap="square" lIns="0" tIns="0" rIns="0" bIns="0" rtlCol="0" anchor="ctr"/>
+          <a:lstStyle/>
+          <a:p>
+            <a:pPr indent="0" marL="0">
+              <a:buNone/>
+            </a:pPr>
+            <a:r>
+              <a:rPr lang="en-US" sz="1500" b="1" dirty="0">
+                <a:solidFill>
+                  <a:srgbClr val="FFFFFF"/>
+                </a:solidFill>
+              </a:rPr>
+              <a:t>Martin Wills</a:t>
+            </a:r>
+            <a:pPr indent="0" marL="0">
+              <a:buNone/>
+            </a:pPr>
+            <a:r>
+              <a:rPr lang="en-US" sz="1500" dirty="0">
+                <a:solidFill>
+                  <a:srgbClr val="FFB347"/>
+                </a:solidFill>
+              </a:rPr>
+              <a:t>   24BCE5255</a:t>
+            </a:r>
+            <a:endParaRPr lang="en-US" sz="1500" dirty="0"/>
+          </a:p>
+        </p:txBody>
+      </p:sp>
+      <p:sp>
+        <p:nvSpPr>
+          <p:cNvPr id="7" name="signal housing"/>
           <p:cNvSpPr/>
           <p:nvPr/>
         </p:nvSpPr>
@@ -4074,7 +4195,7 @@
       </p:sp>
       <p:sp>
         <p:nvSpPr>
-          <p:cNvPr id="5" name="lamp 0"/>
+          <p:cNvPr id="8" name="lamp 0"/>
           <p:cNvSpPr/>
           <p:nvPr/>
         </p:nvSpPr>
@@ -4099,7 +4220,7 @@
       </p:sp>
       <p:sp>
         <p:nvSpPr>
-          <p:cNvPr id="6" name="lamp 1"/>
+          <p:cNvPr id="9" name="lamp 1"/>
           <p:cNvSpPr/>
           <p:nvPr/>
         </p:nvSpPr>
@@ -4124,7 +4245,7 @@
       </p:sp>
       <p:sp>
         <p:nvSpPr>
-          <p:cNvPr id="7" name="lamp 2"/>
+          <p:cNvPr id="10" name="lamp 2"/>
           <p:cNvSpPr/>
           <p:nvPr/>
         </p:nvSpPr>

</xml_diff>